<commit_message>
手动打码 image-10/image-11 中的 API Key，更新 PPTX
</commit_message>
<xml_diff>
--- a/Claude_Code_安装教程.pptx
+++ b/Claude_Code_安装教程.pptx
@@ -5,22 +5,22 @@
     <p:sldMasterId id="2147483648" r:id="rId1"/>
   </p:sldMasterIdLst>
   <p:sldIdLst>
-    <p:sldId id="256" r:id="rId2"/>
-    <p:sldId id="257" r:id="rId3"/>
-    <p:sldId id="258" r:id="rId4"/>
-    <p:sldId id="259" r:id="rId5"/>
-    <p:sldId id="260" r:id="rId6"/>
-    <p:sldId id="261" r:id="rId7"/>
-    <p:sldId id="262" r:id="rId8"/>
-    <p:sldId id="263" r:id="rId9"/>
-    <p:sldId id="264" r:id="rId10"/>
-    <p:sldId id="265" r:id="rId11"/>
-    <p:sldId id="266" r:id="rId12"/>
-    <p:sldId id="267" r:id="rId13"/>
-    <p:sldId id="268" r:id="rId14"/>
-    <p:sldId id="269" r:id="rId15"/>
+    <p:sldId id="256" r:id="rId7"/>
+    <p:sldId id="257" r:id="rId8"/>
+    <p:sldId id="258" r:id="rId9"/>
+    <p:sldId id="259" r:id="rId10"/>
+    <p:sldId id="260" r:id="rId11"/>
+    <p:sldId id="261" r:id="rId12"/>
+    <p:sldId id="262" r:id="rId13"/>
+    <p:sldId id="263" r:id="rId14"/>
+    <p:sldId id="264" r:id="rId15"/>
+    <p:sldId id="265" r:id="rId16"/>
+    <p:sldId id="266" r:id="rId17"/>
+    <p:sldId id="267" r:id="rId18"/>
+    <p:sldId id="268" r:id="rId19"/>
+    <p:sldId id="269" r:id="rId20"/>
   </p:sldIdLst>
-  <p:sldSz cx="12192000" cy="6858000"/>
+  <p:sldSz cx="12191695" cy="6858000" type="screen4x3"/>
   <p:notesSz cx="6858000" cy="9144000"/>
   <p:defaultTextStyle>
     <a:defPPr>
@@ -117,22 +117,6 @@
       </a:defRPr>
     </a:lvl9pPr>
   </p:defaultTextStyle>
-  <p:extLst>
-    <p:ext uri="{EFAFB233-063F-42B5-8137-9DF3F51BA10A}">
-      <p15:sldGuideLst xmlns:p15="http://schemas.microsoft.com/office/powerpoint/2012/main">
-        <p15:guide id="1" orient="horz" pos="2160">
-          <p15:clr>
-            <a:srgbClr val="A4A3A4"/>
-          </p15:clr>
-        </p15:guide>
-        <p15:guide id="2" pos="2880">
-          <p15:clr>
-            <a:srgbClr val="A4A3A4"/>
-          </p15:clr>
-        </p15:guide>
-      </p15:sldGuideLst>
-    </p:ext>
-  </p:extLst>
 </p:presentation>
 </file>
 
@@ -174,9 +158,10 @@
           <a:lstStyle/>
           <a:p>
             <a:r>
-              <a:rPr lang="en-US"/>
+              <a:rPr lang="en-US" smtClean="0"/>
               <a:t>Click to edit Master title style</a:t>
             </a:r>
+            <a:endParaRPr lang="en-US"/>
           </a:p>
         </p:txBody>
       </p:sp>
@@ -292,9 +277,10 @@
           </a:lstStyle>
           <a:p>
             <a:r>
-              <a:rPr lang="en-US"/>
+              <a:rPr lang="en-US" smtClean="0"/>
               <a:t>Click to edit Master subtitle style</a:t>
             </a:r>
+            <a:endParaRPr lang="en-US"/>
           </a:p>
         </p:txBody>
       </p:sp>
@@ -315,7 +301,7 @@
           <a:p>
             <a:fld id="{5BCAD085-E8A6-8845-BD4E-CB4CCA059FC4}" type="datetimeFigureOut">
               <a:rPr lang="en-US" smtClean="0"/>
-              <a:t>6/13/2026</a:t>
+              <a:t>1/27/13</a:t>
             </a:fld>
             <a:endParaRPr lang="en-US"/>
           </a:p>
@@ -409,9 +395,10 @@
           <a:lstStyle/>
           <a:p>
             <a:r>
-              <a:rPr lang="en-US"/>
+              <a:rPr lang="en-US" smtClean="0"/>
               <a:t>Click to edit Master title style</a:t>
             </a:r>
+            <a:endParaRPr lang="en-US"/>
           </a:p>
         </p:txBody>
       </p:sp>
@@ -432,37 +419,38 @@
           <a:p>
             <a:pPr lvl="0"/>
             <a:r>
-              <a:rPr lang="en-US"/>
+              <a:rPr lang="en-US" smtClean="0"/>
               <a:t>Click to edit Master text styles</a:t>
             </a:r>
           </a:p>
           <a:p>
             <a:pPr lvl="1"/>
             <a:r>
-              <a:rPr lang="en-US"/>
+              <a:rPr lang="en-US" smtClean="0"/>
               <a:t>Second level</a:t>
             </a:r>
           </a:p>
           <a:p>
             <a:pPr lvl="2"/>
             <a:r>
-              <a:rPr lang="en-US"/>
+              <a:rPr lang="en-US" smtClean="0"/>
               <a:t>Third level</a:t>
             </a:r>
           </a:p>
           <a:p>
             <a:pPr lvl="3"/>
             <a:r>
-              <a:rPr lang="en-US"/>
+              <a:rPr lang="en-US" smtClean="0"/>
               <a:t>Fourth level</a:t>
             </a:r>
           </a:p>
           <a:p>
             <a:pPr lvl="4"/>
             <a:r>
-              <a:rPr lang="en-US"/>
+              <a:rPr lang="en-US" smtClean="0"/>
               <a:t>Fifth level</a:t>
             </a:r>
+            <a:endParaRPr lang="en-US"/>
           </a:p>
         </p:txBody>
       </p:sp>
@@ -483,7 +471,7 @@
           <a:p>
             <a:fld id="{5BCAD085-E8A6-8845-BD4E-CB4CCA059FC4}" type="datetimeFigureOut">
               <a:rPr lang="en-US" smtClean="0"/>
-              <a:t>6/13/2026</a:t>
+              <a:t>1/27/13</a:t>
             </a:fld>
             <a:endParaRPr lang="en-US"/>
           </a:p>
@@ -582,9 +570,10 @@
           <a:lstStyle/>
           <a:p>
             <a:r>
-              <a:rPr lang="en-US"/>
+              <a:rPr lang="en-US" smtClean="0"/>
               <a:t>Click to edit Master title style</a:t>
             </a:r>
+            <a:endParaRPr lang="en-US"/>
           </a:p>
         </p:txBody>
       </p:sp>
@@ -610,37 +599,38 @@
           <a:p>
             <a:pPr lvl="0"/>
             <a:r>
-              <a:rPr lang="en-US"/>
+              <a:rPr lang="en-US" smtClean="0"/>
               <a:t>Click to edit Master text styles</a:t>
             </a:r>
           </a:p>
           <a:p>
             <a:pPr lvl="1"/>
             <a:r>
-              <a:rPr lang="en-US"/>
+              <a:rPr lang="en-US" smtClean="0"/>
               <a:t>Second level</a:t>
             </a:r>
           </a:p>
           <a:p>
             <a:pPr lvl="2"/>
             <a:r>
-              <a:rPr lang="en-US"/>
+              <a:rPr lang="en-US" smtClean="0"/>
               <a:t>Third level</a:t>
             </a:r>
           </a:p>
           <a:p>
             <a:pPr lvl="3"/>
             <a:r>
-              <a:rPr lang="en-US"/>
+              <a:rPr lang="en-US" smtClean="0"/>
               <a:t>Fourth level</a:t>
             </a:r>
           </a:p>
           <a:p>
             <a:pPr lvl="4"/>
             <a:r>
-              <a:rPr lang="en-US"/>
+              <a:rPr lang="en-US" smtClean="0"/>
               <a:t>Fifth level</a:t>
             </a:r>
+            <a:endParaRPr lang="en-US"/>
           </a:p>
         </p:txBody>
       </p:sp>
@@ -661,7 +651,7 @@
           <a:p>
             <a:fld id="{5BCAD085-E8A6-8845-BD4E-CB4CCA059FC4}" type="datetimeFigureOut">
               <a:rPr lang="en-US" smtClean="0"/>
-              <a:t>6/13/2026</a:t>
+              <a:t>1/27/13</a:t>
             </a:fld>
             <a:endParaRPr lang="en-US"/>
           </a:p>
@@ -755,9 +745,10 @@
           <a:lstStyle/>
           <a:p>
             <a:r>
-              <a:rPr lang="en-US"/>
+              <a:rPr lang="en-US" smtClean="0"/>
               <a:t>Click to edit Master title style</a:t>
             </a:r>
+            <a:endParaRPr lang="en-US"/>
           </a:p>
         </p:txBody>
       </p:sp>
@@ -778,37 +769,38 @@
           <a:p>
             <a:pPr lvl="0"/>
             <a:r>
-              <a:rPr lang="en-US"/>
+              <a:rPr lang="en-US" smtClean="0"/>
               <a:t>Click to edit Master text styles</a:t>
             </a:r>
           </a:p>
           <a:p>
             <a:pPr lvl="1"/>
             <a:r>
-              <a:rPr lang="en-US"/>
+              <a:rPr lang="en-US" smtClean="0"/>
               <a:t>Second level</a:t>
             </a:r>
           </a:p>
           <a:p>
             <a:pPr lvl="2"/>
             <a:r>
-              <a:rPr lang="en-US"/>
+              <a:rPr lang="en-US" smtClean="0"/>
               <a:t>Third level</a:t>
             </a:r>
           </a:p>
           <a:p>
             <a:pPr lvl="3"/>
             <a:r>
-              <a:rPr lang="en-US"/>
+              <a:rPr lang="en-US" smtClean="0"/>
               <a:t>Fourth level</a:t>
             </a:r>
           </a:p>
           <a:p>
             <a:pPr lvl="4"/>
             <a:r>
-              <a:rPr lang="en-US"/>
+              <a:rPr lang="en-US" smtClean="0"/>
               <a:t>Fifth level</a:t>
             </a:r>
+            <a:endParaRPr lang="en-US"/>
           </a:p>
         </p:txBody>
       </p:sp>
@@ -829,7 +821,7 @@
           <a:p>
             <a:fld id="{5BCAD085-E8A6-8845-BD4E-CB4CCA059FC4}" type="datetimeFigureOut">
               <a:rPr lang="en-US" smtClean="0"/>
-              <a:t>6/13/2026</a:t>
+              <a:t>1/27/13</a:t>
             </a:fld>
             <a:endParaRPr lang="en-US"/>
           </a:p>
@@ -932,9 +924,10 @@
           </a:lstStyle>
           <a:p>
             <a:r>
-              <a:rPr lang="en-US"/>
+              <a:rPr lang="en-US" smtClean="0"/>
               <a:t>Click to edit Master title style</a:t>
             </a:r>
+            <a:endParaRPr lang="en-US"/>
           </a:p>
         </p:txBody>
       </p:sp>
@@ -1051,7 +1044,7 @@
           <a:p>
             <a:pPr lvl="0"/>
             <a:r>
-              <a:rPr lang="en-US"/>
+              <a:rPr lang="en-US" smtClean="0"/>
               <a:t>Click to edit Master text styles</a:t>
             </a:r>
           </a:p>
@@ -1074,7 +1067,7 @@
           <a:p>
             <a:fld id="{5BCAD085-E8A6-8845-BD4E-CB4CCA059FC4}" type="datetimeFigureOut">
               <a:rPr lang="en-US" smtClean="0"/>
-              <a:t>6/13/2026</a:t>
+              <a:t>1/27/13</a:t>
             </a:fld>
             <a:endParaRPr lang="en-US"/>
           </a:p>
@@ -1168,9 +1161,10 @@
           <a:lstStyle/>
           <a:p>
             <a:r>
-              <a:rPr lang="en-US"/>
+              <a:rPr lang="en-US" smtClean="0"/>
               <a:t>Click to edit Master title style</a:t>
             </a:r>
+            <a:endParaRPr lang="en-US"/>
           </a:p>
         </p:txBody>
       </p:sp>
@@ -1224,37 +1218,38 @@
           <a:p>
             <a:pPr lvl="0"/>
             <a:r>
-              <a:rPr lang="en-US"/>
+              <a:rPr lang="en-US" smtClean="0"/>
               <a:t>Click to edit Master text styles</a:t>
             </a:r>
           </a:p>
           <a:p>
             <a:pPr lvl="1"/>
             <a:r>
-              <a:rPr lang="en-US"/>
+              <a:rPr lang="en-US" smtClean="0"/>
               <a:t>Second level</a:t>
             </a:r>
           </a:p>
           <a:p>
             <a:pPr lvl="2"/>
             <a:r>
-              <a:rPr lang="en-US"/>
+              <a:rPr lang="en-US" smtClean="0"/>
               <a:t>Third level</a:t>
             </a:r>
           </a:p>
           <a:p>
             <a:pPr lvl="3"/>
             <a:r>
-              <a:rPr lang="en-US"/>
+              <a:rPr lang="en-US" smtClean="0"/>
               <a:t>Fourth level</a:t>
             </a:r>
           </a:p>
           <a:p>
             <a:pPr lvl="4"/>
             <a:r>
-              <a:rPr lang="en-US"/>
+              <a:rPr lang="en-US" smtClean="0"/>
               <a:t>Fifth level</a:t>
             </a:r>
+            <a:endParaRPr lang="en-US"/>
           </a:p>
         </p:txBody>
       </p:sp>
@@ -1308,37 +1303,38 @@
           <a:p>
             <a:pPr lvl="0"/>
             <a:r>
-              <a:rPr lang="en-US"/>
+              <a:rPr lang="en-US" smtClean="0"/>
               <a:t>Click to edit Master text styles</a:t>
             </a:r>
           </a:p>
           <a:p>
             <a:pPr lvl="1"/>
             <a:r>
-              <a:rPr lang="en-US"/>
+              <a:rPr lang="en-US" smtClean="0"/>
               <a:t>Second level</a:t>
             </a:r>
           </a:p>
           <a:p>
             <a:pPr lvl="2"/>
             <a:r>
-              <a:rPr lang="en-US"/>
+              <a:rPr lang="en-US" smtClean="0"/>
               <a:t>Third level</a:t>
             </a:r>
           </a:p>
           <a:p>
             <a:pPr lvl="3"/>
             <a:r>
-              <a:rPr lang="en-US"/>
+              <a:rPr lang="en-US" smtClean="0"/>
               <a:t>Fourth level</a:t>
             </a:r>
           </a:p>
           <a:p>
             <a:pPr lvl="4"/>
             <a:r>
-              <a:rPr lang="en-US"/>
+              <a:rPr lang="en-US" smtClean="0"/>
               <a:t>Fifth level</a:t>
             </a:r>
+            <a:endParaRPr lang="en-US"/>
           </a:p>
         </p:txBody>
       </p:sp>
@@ -1359,7 +1355,7 @@
           <a:p>
             <a:fld id="{5BCAD085-E8A6-8845-BD4E-CB4CCA059FC4}" type="datetimeFigureOut">
               <a:rPr lang="en-US" smtClean="0"/>
-              <a:t>6/13/2026</a:t>
+              <a:t>1/27/13</a:t>
             </a:fld>
             <a:endParaRPr lang="en-US"/>
           </a:p>
@@ -1457,9 +1453,10 @@
           </a:lstStyle>
           <a:p>
             <a:r>
-              <a:rPr lang="en-US"/>
+              <a:rPr lang="en-US" smtClean="0"/>
               <a:t>Click to edit Master title style</a:t>
             </a:r>
+            <a:endParaRPr lang="en-US"/>
           </a:p>
         </p:txBody>
       </p:sp>
@@ -1522,7 +1519,7 @@
           <a:p>
             <a:pPr lvl="0"/>
             <a:r>
-              <a:rPr lang="en-US"/>
+              <a:rPr lang="en-US" smtClean="0"/>
               <a:t>Click to edit Master text styles</a:t>
             </a:r>
           </a:p>
@@ -1578,37 +1575,38 @@
           <a:p>
             <a:pPr lvl="0"/>
             <a:r>
-              <a:rPr lang="en-US"/>
+              <a:rPr lang="en-US" smtClean="0"/>
               <a:t>Click to edit Master text styles</a:t>
             </a:r>
           </a:p>
           <a:p>
             <a:pPr lvl="1"/>
             <a:r>
-              <a:rPr lang="en-US"/>
+              <a:rPr lang="en-US" smtClean="0"/>
               <a:t>Second level</a:t>
             </a:r>
           </a:p>
           <a:p>
             <a:pPr lvl="2"/>
             <a:r>
-              <a:rPr lang="en-US"/>
+              <a:rPr lang="en-US" smtClean="0"/>
               <a:t>Third level</a:t>
             </a:r>
           </a:p>
           <a:p>
             <a:pPr lvl="3"/>
             <a:r>
-              <a:rPr lang="en-US"/>
+              <a:rPr lang="en-US" smtClean="0"/>
               <a:t>Fourth level</a:t>
             </a:r>
           </a:p>
           <a:p>
             <a:pPr lvl="4"/>
             <a:r>
-              <a:rPr lang="en-US"/>
+              <a:rPr lang="en-US" smtClean="0"/>
               <a:t>Fifth level</a:t>
             </a:r>
+            <a:endParaRPr lang="en-US"/>
           </a:p>
         </p:txBody>
       </p:sp>
@@ -1671,7 +1669,7 @@
           <a:p>
             <a:pPr lvl="0"/>
             <a:r>
-              <a:rPr lang="en-US"/>
+              <a:rPr lang="en-US" smtClean="0"/>
               <a:t>Click to edit Master text styles</a:t>
             </a:r>
           </a:p>
@@ -1727,37 +1725,38 @@
           <a:p>
             <a:pPr lvl="0"/>
             <a:r>
-              <a:rPr lang="en-US"/>
+              <a:rPr lang="en-US" smtClean="0"/>
               <a:t>Click to edit Master text styles</a:t>
             </a:r>
           </a:p>
           <a:p>
             <a:pPr lvl="1"/>
             <a:r>
-              <a:rPr lang="en-US"/>
+              <a:rPr lang="en-US" smtClean="0"/>
               <a:t>Second level</a:t>
             </a:r>
           </a:p>
           <a:p>
             <a:pPr lvl="2"/>
             <a:r>
-              <a:rPr lang="en-US"/>
+              <a:rPr lang="en-US" smtClean="0"/>
               <a:t>Third level</a:t>
             </a:r>
           </a:p>
           <a:p>
             <a:pPr lvl="3"/>
             <a:r>
-              <a:rPr lang="en-US"/>
+              <a:rPr lang="en-US" smtClean="0"/>
               <a:t>Fourth level</a:t>
             </a:r>
           </a:p>
           <a:p>
             <a:pPr lvl="4"/>
             <a:r>
-              <a:rPr lang="en-US"/>
+              <a:rPr lang="en-US" smtClean="0"/>
               <a:t>Fifth level</a:t>
             </a:r>
+            <a:endParaRPr lang="en-US"/>
           </a:p>
         </p:txBody>
       </p:sp>
@@ -1778,7 +1777,7 @@
           <a:p>
             <a:fld id="{5BCAD085-E8A6-8845-BD4E-CB4CCA059FC4}" type="datetimeFigureOut">
               <a:rPr lang="en-US" smtClean="0"/>
-              <a:t>6/13/2026</a:t>
+              <a:t>1/27/13</a:t>
             </a:fld>
             <a:endParaRPr lang="en-US"/>
           </a:p>
@@ -1872,9 +1871,10 @@
           <a:lstStyle/>
           <a:p>
             <a:r>
-              <a:rPr lang="en-US"/>
+              <a:rPr lang="en-US" smtClean="0"/>
               <a:t>Click to edit Master title style</a:t>
             </a:r>
+            <a:endParaRPr lang="en-US"/>
           </a:p>
         </p:txBody>
       </p:sp>
@@ -1895,7 +1895,7 @@
           <a:p>
             <a:fld id="{5BCAD085-E8A6-8845-BD4E-CB4CCA059FC4}" type="datetimeFigureOut">
               <a:rPr lang="en-US" smtClean="0"/>
-              <a:t>6/13/2026</a:t>
+              <a:t>1/27/13</a:t>
             </a:fld>
             <a:endParaRPr lang="en-US"/>
           </a:p>
@@ -1990,7 +1990,7 @@
           <a:p>
             <a:fld id="{5BCAD085-E8A6-8845-BD4E-CB4CCA059FC4}" type="datetimeFigureOut">
               <a:rPr lang="en-US" smtClean="0"/>
-              <a:t>6/13/2026</a:t>
+              <a:t>1/27/13</a:t>
             </a:fld>
             <a:endParaRPr lang="en-US"/>
           </a:p>
@@ -2093,9 +2093,10 @@
           </a:lstStyle>
           <a:p>
             <a:r>
-              <a:rPr lang="en-US"/>
+              <a:rPr lang="en-US" smtClean="0"/>
               <a:t>Click to edit Master title style</a:t>
             </a:r>
+            <a:endParaRPr lang="en-US"/>
           </a:p>
         </p:txBody>
       </p:sp>
@@ -2149,37 +2150,38 @@
           <a:p>
             <a:pPr lvl="0"/>
             <a:r>
-              <a:rPr lang="en-US"/>
+              <a:rPr lang="en-US" smtClean="0"/>
               <a:t>Click to edit Master text styles</a:t>
             </a:r>
           </a:p>
           <a:p>
             <a:pPr lvl="1"/>
             <a:r>
-              <a:rPr lang="en-US"/>
+              <a:rPr lang="en-US" smtClean="0"/>
               <a:t>Second level</a:t>
             </a:r>
           </a:p>
           <a:p>
             <a:pPr lvl="2"/>
             <a:r>
-              <a:rPr lang="en-US"/>
+              <a:rPr lang="en-US" smtClean="0"/>
               <a:t>Third level</a:t>
             </a:r>
           </a:p>
           <a:p>
             <a:pPr lvl="3"/>
             <a:r>
-              <a:rPr lang="en-US"/>
+              <a:rPr lang="en-US" smtClean="0"/>
               <a:t>Fourth level</a:t>
             </a:r>
           </a:p>
           <a:p>
             <a:pPr lvl="4"/>
             <a:r>
-              <a:rPr lang="en-US"/>
+              <a:rPr lang="en-US" smtClean="0"/>
               <a:t>Fifth level</a:t>
             </a:r>
+            <a:endParaRPr lang="en-US"/>
           </a:p>
         </p:txBody>
       </p:sp>
@@ -2242,7 +2244,7 @@
           <a:p>
             <a:pPr lvl="0"/>
             <a:r>
-              <a:rPr lang="en-US"/>
+              <a:rPr lang="en-US" smtClean="0"/>
               <a:t>Click to edit Master text styles</a:t>
             </a:r>
           </a:p>
@@ -2265,7 +2267,7 @@
           <a:p>
             <a:fld id="{5BCAD085-E8A6-8845-BD4E-CB4CCA059FC4}" type="datetimeFigureOut">
               <a:rPr lang="en-US" smtClean="0"/>
-              <a:t>6/13/2026</a:t>
+              <a:t>1/27/13</a:t>
             </a:fld>
             <a:endParaRPr lang="en-US"/>
           </a:p>
@@ -2368,9 +2370,10 @@
           </a:lstStyle>
           <a:p>
             <a:r>
-              <a:rPr lang="en-US"/>
+              <a:rPr lang="en-US" smtClean="0"/>
               <a:t>Click to edit Master title style</a:t>
             </a:r>
+            <a:endParaRPr lang="en-US"/>
           </a:p>
         </p:txBody>
       </p:sp>
@@ -2494,7 +2497,7 @@
           <a:p>
             <a:pPr lvl="0"/>
             <a:r>
-              <a:rPr lang="en-US"/>
+              <a:rPr lang="en-US" smtClean="0"/>
               <a:t>Click to edit Master text styles</a:t>
             </a:r>
           </a:p>
@@ -2517,7 +2520,7 @@
           <a:p>
             <a:fld id="{5BCAD085-E8A6-8845-BD4E-CB4CCA059FC4}" type="datetimeFigureOut">
               <a:rPr lang="en-US" smtClean="0"/>
-              <a:t>6/13/2026</a:t>
+              <a:t>1/27/13</a:t>
             </a:fld>
             <a:endParaRPr lang="en-US"/>
           </a:p>
@@ -2626,9 +2629,10 @@
           <a:lstStyle/>
           <a:p>
             <a:r>
-              <a:rPr lang="en-US"/>
+              <a:rPr lang="en-US" smtClean="0"/>
               <a:t>Click to edit Master title style</a:t>
             </a:r>
+            <a:endParaRPr lang="en-US"/>
           </a:p>
         </p:txBody>
       </p:sp>
@@ -2659,37 +2663,38 @@
           <a:p>
             <a:pPr lvl="0"/>
             <a:r>
-              <a:rPr lang="en-US"/>
+              <a:rPr lang="en-US" smtClean="0"/>
               <a:t>Click to edit Master text styles</a:t>
             </a:r>
           </a:p>
           <a:p>
             <a:pPr lvl="1"/>
             <a:r>
-              <a:rPr lang="en-US"/>
+              <a:rPr lang="en-US" smtClean="0"/>
               <a:t>Second level</a:t>
             </a:r>
           </a:p>
           <a:p>
             <a:pPr lvl="2"/>
             <a:r>
-              <a:rPr lang="en-US"/>
+              <a:rPr lang="en-US" smtClean="0"/>
               <a:t>Third level</a:t>
             </a:r>
           </a:p>
           <a:p>
             <a:pPr lvl="3"/>
             <a:r>
-              <a:rPr lang="en-US"/>
+              <a:rPr lang="en-US" smtClean="0"/>
               <a:t>Fourth level</a:t>
             </a:r>
           </a:p>
           <a:p>
             <a:pPr lvl="4"/>
             <a:r>
-              <a:rPr lang="en-US"/>
+              <a:rPr lang="en-US" smtClean="0"/>
               <a:t>Fifth level</a:t>
             </a:r>
+            <a:endParaRPr lang="en-US"/>
           </a:p>
         </p:txBody>
       </p:sp>
@@ -2728,7 +2733,7 @@
           <a:p>
             <a:fld id="{5BCAD085-E8A6-8845-BD4E-CB4CCA059FC4}" type="datetimeFigureOut">
               <a:rPr lang="en-US" smtClean="0"/>
-              <a:t>6/13/2026</a:t>
+              <a:t>1/27/13</a:t>
             </a:fld>
             <a:endParaRPr lang="en-US"/>
           </a:p>
@@ -3087,7 +3092,7 @@
 </file>
 
 <file path=ppt/slides/slide1.xml><?xml version="1.0" encoding="utf-8"?>
-<p:sld xmlns:a="http://schemas.openxmlformats.org/drawingml/2006/main" xmlns:r="http://schemas.openxmlformats.org/officeDocument/2006/relationships" xmlns:p="http://schemas.openxmlformats.org/presentationml/2006/main">
+<p:sld xmlns:a="http://schemas.openxmlformats.org/drawingml/2006/main" xmlns:p="http://schemas.openxmlformats.org/presentationml/2006/main" xmlns:r="http://schemas.openxmlformats.org/officeDocument/2006/relationships">
   <p:cSld>
     <p:bg>
       <p:bgPr>
@@ -3103,14 +3108,7 @@
         <p:cNvGrpSpPr/>
         <p:nvPr/>
       </p:nvGrpSpPr>
-      <p:grpSpPr>
-        <a:xfrm>
-          <a:off x="0" y="0"/>
-          <a:ext cx="0" cy="0"/>
-          <a:chOff x="0" y="0"/>
-          <a:chExt cx="0" cy="0"/>
-        </a:xfrm>
-      </p:grpSpPr>
+      <p:grpSpPr/>
       <p:sp>
         <p:nvSpPr>
           <p:cNvPr id="2" name="Rectangle 1"/>
@@ -3151,7 +3149,6 @@
           <a:lstStyle/>
           <a:p>
             <a:pPr algn="ctr"/>
-            <a:endParaRPr/>
           </a:p>
         </p:txBody>
       </p:sp>
@@ -3195,7 +3192,6 @@
           <a:lstStyle/>
           <a:p>
             <a:pPr algn="ctr"/>
-            <a:endParaRPr/>
           </a:p>
         </p:txBody>
       </p:sp>
@@ -3368,7 +3364,7 @@
 </file>
 
 <file path=ppt/slides/slide10.xml><?xml version="1.0" encoding="utf-8"?>
-<p:sld xmlns:a="http://schemas.openxmlformats.org/drawingml/2006/main" xmlns:r="http://schemas.openxmlformats.org/officeDocument/2006/relationships" xmlns:p="http://schemas.openxmlformats.org/presentationml/2006/main">
+<p:sld xmlns:a="http://schemas.openxmlformats.org/drawingml/2006/main" xmlns:p="http://schemas.openxmlformats.org/presentationml/2006/main" xmlns:r="http://schemas.openxmlformats.org/officeDocument/2006/relationships">
   <p:cSld>
     <p:bg>
       <p:bgPr>
@@ -3384,14 +3380,7 @@
         <p:cNvGrpSpPr/>
         <p:nvPr/>
       </p:nvGrpSpPr>
-      <p:grpSpPr>
-        <a:xfrm>
-          <a:off x="0" y="0"/>
-          <a:ext cx="0" cy="0"/>
-          <a:chOff x="0" y="0"/>
-          <a:chExt cx="0" cy="0"/>
-        </a:xfrm>
-      </p:grpSpPr>
+      <p:grpSpPr/>
       <p:sp>
         <p:nvSpPr>
           <p:cNvPr id="2" name="Rectangle 1"/>
@@ -3432,7 +3421,6 @@
           <a:lstStyle/>
           <a:p>
             <a:pPr algn="ctr"/>
-            <a:endParaRPr/>
           </a:p>
         </p:txBody>
       </p:sp>
@@ -3609,7 +3597,6 @@
           <a:lstStyle/>
           <a:p>
             <a:pPr algn="ctr"/>
-            <a:endParaRPr/>
           </a:p>
         </p:txBody>
       </p:sp>
@@ -3653,7 +3640,6 @@
           <a:lstStyle/>
           <a:p>
             <a:pPr algn="ctr"/>
-            <a:endParaRPr/>
           </a:p>
         </p:txBody>
       </p:sp>
@@ -3769,7 +3755,6 @@
                 <a:latin typeface="Microsoft YaHei"/>
               </a:defRPr>
             </a:pPr>
-            <a:endParaRPr/>
           </a:p>
           <a:p>
             <a:pPr algn="l">
@@ -3851,7 +3836,6 @@
           <a:lstStyle/>
           <a:p>
             <a:pPr algn="ctr"/>
-            <a:endParaRPr/>
           </a:p>
         </p:txBody>
       </p:sp>
@@ -3895,7 +3879,6 @@
           <a:lstStyle/>
           <a:p>
             <a:pPr algn="ctr"/>
-            <a:endParaRPr/>
           </a:p>
         </p:txBody>
       </p:sp>
@@ -4011,7 +3994,6 @@
                 <a:latin typeface="Microsoft YaHei"/>
               </a:defRPr>
             </a:pPr>
-            <a:endParaRPr/>
           </a:p>
           <a:p>
             <a:pPr algn="l">
@@ -4173,7 +4155,6 @@
           <a:lstStyle/>
           <a:p>
             <a:pPr algn="ctr"/>
-            <a:endParaRPr/>
           </a:p>
         </p:txBody>
       </p:sp>
@@ -4241,7 +4222,6 @@
           <a:lstStyle/>
           <a:p>
             <a:pPr algn="ctr"/>
-            <a:endParaRPr/>
           </a:p>
         </p:txBody>
       </p:sp>
@@ -4309,7 +4289,6 @@
           <a:lstStyle/>
           <a:p>
             <a:pPr algn="ctr"/>
-            <a:endParaRPr/>
           </a:p>
         </p:txBody>
       </p:sp>
@@ -4485,7 +4464,7 @@
 </file>
 
 <file path=ppt/slides/slide11.xml><?xml version="1.0" encoding="utf-8"?>
-<p:sld xmlns:a="http://schemas.openxmlformats.org/drawingml/2006/main" xmlns:r="http://schemas.openxmlformats.org/officeDocument/2006/relationships" xmlns:p="http://schemas.openxmlformats.org/presentationml/2006/main">
+<p:sld xmlns:a="http://schemas.openxmlformats.org/drawingml/2006/main" xmlns:p="http://schemas.openxmlformats.org/presentationml/2006/main" xmlns:r="http://schemas.openxmlformats.org/officeDocument/2006/relationships">
   <p:cSld>
     <p:bg>
       <p:bgPr>
@@ -4501,14 +4480,7 @@
         <p:cNvGrpSpPr/>
         <p:nvPr/>
       </p:nvGrpSpPr>
-      <p:grpSpPr>
-        <a:xfrm>
-          <a:off x="0" y="0"/>
-          <a:ext cx="0" cy="0"/>
-          <a:chOff x="0" y="0"/>
-          <a:chExt cx="0" cy="0"/>
-        </a:xfrm>
-      </p:grpSpPr>
+      <p:grpSpPr/>
       <p:sp>
         <p:nvSpPr>
           <p:cNvPr id="2" name="Rectangle 1"/>
@@ -4549,7 +4521,6 @@
           <a:lstStyle/>
           <a:p>
             <a:pPr algn="ctr"/>
-            <a:endParaRPr/>
           </a:p>
         </p:txBody>
       </p:sp>
@@ -4726,7 +4697,6 @@
           <a:lstStyle/>
           <a:p>
             <a:pPr algn="ctr"/>
-            <a:endParaRPr/>
           </a:p>
         </p:txBody>
       </p:sp>
@@ -5093,7 +5063,6 @@
           <a:lstStyle/>
           <a:p>
             <a:pPr algn="ctr"/>
-            <a:endParaRPr/>
           </a:p>
         </p:txBody>
       </p:sp>
@@ -5204,7 +5173,7 @@
 </file>
 
 <file path=ppt/slides/slide12.xml><?xml version="1.0" encoding="utf-8"?>
-<p:sld xmlns:a="http://schemas.openxmlformats.org/drawingml/2006/main" xmlns:r="http://schemas.openxmlformats.org/officeDocument/2006/relationships" xmlns:p="http://schemas.openxmlformats.org/presentationml/2006/main">
+<p:sld xmlns:a="http://schemas.openxmlformats.org/drawingml/2006/main" xmlns:p="http://schemas.openxmlformats.org/presentationml/2006/main" xmlns:r="http://schemas.openxmlformats.org/officeDocument/2006/relationships">
   <p:cSld>
     <p:bg>
       <p:bgPr>
@@ -5220,14 +5189,7 @@
         <p:cNvGrpSpPr/>
         <p:nvPr/>
       </p:nvGrpSpPr>
-      <p:grpSpPr>
-        <a:xfrm>
-          <a:off x="0" y="0"/>
-          <a:ext cx="0" cy="0"/>
-          <a:chOff x="0" y="0"/>
-          <a:chExt cx="0" cy="0"/>
-        </a:xfrm>
-      </p:grpSpPr>
+      <p:grpSpPr/>
       <p:sp>
         <p:nvSpPr>
           <p:cNvPr id="2" name="Rectangle 1"/>
@@ -5268,7 +5230,6 @@
           <a:lstStyle/>
           <a:p>
             <a:pPr algn="ctr"/>
-            <a:endParaRPr/>
           </a:p>
         </p:txBody>
       </p:sp>
@@ -5632,7 +5593,6 @@
           <a:lstStyle/>
           <a:p>
             <a:pPr algn="ctr"/>
-            <a:endParaRPr/>
           </a:p>
         </p:txBody>
       </p:sp>
@@ -5785,7 +5745,6 @@
                 <a:latin typeface="Microsoft YaHei"/>
               </a:defRPr>
             </a:pPr>
-            <a:endParaRPr/>
           </a:p>
           <a:p>
             <a:pPr algn="l">
@@ -5867,7 +5826,6 @@
           <a:lstStyle/>
           <a:p>
             <a:pPr algn="ctr"/>
-            <a:endParaRPr/>
           </a:p>
         </p:txBody>
       </p:sp>
@@ -5904,7 +5862,7 @@
 </file>
 
 <file path=ppt/slides/slide13.xml><?xml version="1.0" encoding="utf-8"?>
-<p:sld xmlns:a="http://schemas.openxmlformats.org/drawingml/2006/main" xmlns:r="http://schemas.openxmlformats.org/officeDocument/2006/relationships" xmlns:p="http://schemas.openxmlformats.org/presentationml/2006/main">
+<p:sld xmlns:a="http://schemas.openxmlformats.org/drawingml/2006/main" xmlns:p="http://schemas.openxmlformats.org/presentationml/2006/main" xmlns:r="http://schemas.openxmlformats.org/officeDocument/2006/relationships">
   <p:cSld>
     <p:bg>
       <p:bgPr>
@@ -5920,14 +5878,7 @@
         <p:cNvGrpSpPr/>
         <p:nvPr/>
       </p:nvGrpSpPr>
-      <p:grpSpPr>
-        <a:xfrm>
-          <a:off x="0" y="0"/>
-          <a:ext cx="0" cy="0"/>
-          <a:chOff x="0" y="0"/>
-          <a:chExt cx="0" cy="0"/>
-        </a:xfrm>
-      </p:grpSpPr>
+      <p:grpSpPr/>
       <p:sp>
         <p:nvSpPr>
           <p:cNvPr id="2" name="Rectangle 1"/>
@@ -5968,7 +5919,6 @@
           <a:lstStyle/>
           <a:p>
             <a:pPr algn="ctr"/>
-            <a:endParaRPr/>
           </a:p>
         </p:txBody>
       </p:sp>
@@ -6092,7 +6042,6 @@
           <a:lstStyle/>
           <a:p>
             <a:pPr algn="ctr"/>
-            <a:endParaRPr/>
           </a:p>
         </p:txBody>
       </p:sp>
@@ -6136,7 +6085,6 @@
           <a:lstStyle/>
           <a:p>
             <a:pPr algn="ctr"/>
-            <a:endParaRPr/>
           </a:p>
         </p:txBody>
       </p:sp>
@@ -6298,7 +6246,6 @@
           <a:lstStyle/>
           <a:p>
             <a:pPr algn="ctr"/>
-            <a:endParaRPr/>
           </a:p>
         </p:txBody>
       </p:sp>
@@ -6342,7 +6289,6 @@
           <a:lstStyle/>
           <a:p>
             <a:pPr algn="ctr"/>
-            <a:endParaRPr/>
           </a:p>
         </p:txBody>
       </p:sp>
@@ -6504,7 +6450,6 @@
           <a:lstStyle/>
           <a:p>
             <a:pPr algn="ctr"/>
-            <a:endParaRPr/>
           </a:p>
         </p:txBody>
       </p:sp>
@@ -6548,7 +6493,6 @@
           <a:lstStyle/>
           <a:p>
             <a:pPr algn="ctr"/>
-            <a:endParaRPr/>
           </a:p>
         </p:txBody>
       </p:sp>
@@ -6710,7 +6654,6 @@
           <a:lstStyle/>
           <a:p>
             <a:pPr algn="ctr"/>
-            <a:endParaRPr/>
           </a:p>
         </p:txBody>
       </p:sp>
@@ -6754,7 +6697,6 @@
           <a:lstStyle/>
           <a:p>
             <a:pPr algn="ctr"/>
-            <a:endParaRPr/>
           </a:p>
         </p:txBody>
       </p:sp>
@@ -6916,7 +6858,6 @@
           <a:lstStyle/>
           <a:p>
             <a:pPr algn="ctr"/>
-            <a:endParaRPr/>
           </a:p>
         </p:txBody>
       </p:sp>
@@ -6960,7 +6901,6 @@
           <a:lstStyle/>
           <a:p>
             <a:pPr algn="ctr"/>
-            <a:endParaRPr/>
           </a:p>
         </p:txBody>
       </p:sp>
@@ -7122,7 +7062,6 @@
           <a:lstStyle/>
           <a:p>
             <a:pPr algn="ctr"/>
-            <a:endParaRPr/>
           </a:p>
         </p:txBody>
       </p:sp>
@@ -7166,7 +7105,6 @@
           <a:lstStyle/>
           <a:p>
             <a:pPr algn="ctr"/>
-            <a:endParaRPr/>
           </a:p>
         </p:txBody>
       </p:sp>
@@ -7337,7 +7275,7 @@
 </file>
 
 <file path=ppt/slides/slide14.xml><?xml version="1.0" encoding="utf-8"?>
-<p:sld xmlns:a="http://schemas.openxmlformats.org/drawingml/2006/main" xmlns:r="http://schemas.openxmlformats.org/officeDocument/2006/relationships" xmlns:p="http://schemas.openxmlformats.org/presentationml/2006/main">
+<p:sld xmlns:a="http://schemas.openxmlformats.org/drawingml/2006/main" xmlns:p="http://schemas.openxmlformats.org/presentationml/2006/main" xmlns:r="http://schemas.openxmlformats.org/officeDocument/2006/relationships">
   <p:cSld>
     <p:bg>
       <p:bgPr>
@@ -7353,14 +7291,7 @@
         <p:cNvGrpSpPr/>
         <p:nvPr/>
       </p:nvGrpSpPr>
-      <p:grpSpPr>
-        <a:xfrm>
-          <a:off x="0" y="0"/>
-          <a:ext cx="0" cy="0"/>
-          <a:chOff x="0" y="0"/>
-          <a:chExt cx="0" cy="0"/>
-        </a:xfrm>
-      </p:grpSpPr>
+      <p:grpSpPr/>
       <p:sp>
         <p:nvSpPr>
           <p:cNvPr id="2" name="Rectangle 1"/>
@@ -7401,7 +7332,6 @@
           <a:lstStyle/>
           <a:p>
             <a:pPr algn="ctr"/>
-            <a:endParaRPr/>
           </a:p>
         </p:txBody>
       </p:sp>
@@ -7525,7 +7455,6 @@
           <a:lstStyle/>
           <a:p>
             <a:pPr algn="ctr"/>
-            <a:endParaRPr/>
           </a:p>
         </p:txBody>
       </p:sp>
@@ -7569,7 +7498,6 @@
           <a:lstStyle/>
           <a:p>
             <a:pPr algn="ctr"/>
-            <a:endParaRPr/>
           </a:p>
         </p:txBody>
       </p:sp>
@@ -7733,7 +7661,6 @@
           <a:lstStyle/>
           <a:p>
             <a:pPr algn="ctr"/>
-            <a:endParaRPr/>
           </a:p>
         </p:txBody>
       </p:sp>
@@ -7777,7 +7704,6 @@
           <a:lstStyle/>
           <a:p>
             <a:pPr algn="ctr"/>
-            <a:endParaRPr/>
           </a:p>
         </p:txBody>
       </p:sp>
@@ -7941,7 +7867,6 @@
           <a:lstStyle/>
           <a:p>
             <a:pPr algn="ctr"/>
-            <a:endParaRPr/>
           </a:p>
         </p:txBody>
       </p:sp>
@@ -7985,7 +7910,6 @@
           <a:lstStyle/>
           <a:p>
             <a:pPr algn="ctr"/>
-            <a:endParaRPr/>
           </a:p>
         </p:txBody>
       </p:sp>
@@ -8149,7 +8073,6 @@
           <a:lstStyle/>
           <a:p>
             <a:pPr algn="ctr"/>
-            <a:endParaRPr/>
           </a:p>
         </p:txBody>
       </p:sp>
@@ -8193,7 +8116,6 @@
           <a:lstStyle/>
           <a:p>
             <a:pPr algn="ctr"/>
-            <a:endParaRPr/>
           </a:p>
         </p:txBody>
       </p:sp>
@@ -8357,7 +8279,6 @@
           <a:lstStyle/>
           <a:p>
             <a:pPr algn="ctr"/>
-            <a:endParaRPr/>
           </a:p>
         </p:txBody>
       </p:sp>
@@ -8401,7 +8322,6 @@
           <a:lstStyle/>
           <a:p>
             <a:pPr algn="ctr"/>
-            <a:endParaRPr/>
           </a:p>
         </p:txBody>
       </p:sp>
@@ -8565,7 +8485,6 @@
           <a:lstStyle/>
           <a:p>
             <a:pPr algn="ctr"/>
-            <a:endParaRPr/>
           </a:p>
         </p:txBody>
       </p:sp>
@@ -8609,7 +8528,6 @@
           <a:lstStyle/>
           <a:p>
             <a:pPr algn="ctr"/>
-            <a:endParaRPr/>
           </a:p>
         </p:txBody>
       </p:sp>
@@ -8801,7 +8719,7 @@
 </file>
 
 <file path=ppt/slides/slide2.xml><?xml version="1.0" encoding="utf-8"?>
-<p:sld xmlns:a="http://schemas.openxmlformats.org/drawingml/2006/main" xmlns:r="http://schemas.openxmlformats.org/officeDocument/2006/relationships" xmlns:p="http://schemas.openxmlformats.org/presentationml/2006/main">
+<p:sld xmlns:a="http://schemas.openxmlformats.org/drawingml/2006/main" xmlns:p="http://schemas.openxmlformats.org/presentationml/2006/main" xmlns:r="http://schemas.openxmlformats.org/officeDocument/2006/relationships">
   <p:cSld>
     <p:bg>
       <p:bgPr>
@@ -8817,14 +8735,7 @@
         <p:cNvGrpSpPr/>
         <p:nvPr/>
       </p:nvGrpSpPr>
-      <p:grpSpPr>
-        <a:xfrm>
-          <a:off x="0" y="0"/>
-          <a:ext cx="0" cy="0"/>
-          <a:chOff x="0" y="0"/>
-          <a:chExt cx="0" cy="0"/>
-        </a:xfrm>
-      </p:grpSpPr>
+      <p:grpSpPr/>
       <p:sp>
         <p:nvSpPr>
           <p:cNvPr id="2" name="Rectangle 1"/>
@@ -8865,7 +8776,6 @@
           <a:lstStyle/>
           <a:p>
             <a:pPr algn="ctr"/>
-            <a:endParaRPr/>
           </a:p>
         </p:txBody>
       </p:sp>
@@ -8989,7 +8899,6 @@
           <a:lstStyle/>
           <a:p>
             <a:pPr algn="ctr"/>
-            <a:endParaRPr/>
           </a:p>
         </p:txBody>
       </p:sp>
@@ -9166,7 +9075,6 @@
           <a:lstStyle/>
           <a:p>
             <a:pPr algn="ctr"/>
-            <a:endParaRPr/>
           </a:p>
         </p:txBody>
       </p:sp>
@@ -9343,7 +9251,6 @@
           <a:lstStyle/>
           <a:p>
             <a:pPr algn="ctr"/>
-            <a:endParaRPr/>
           </a:p>
         </p:txBody>
       </p:sp>
@@ -9520,7 +9427,6 @@
           <a:lstStyle/>
           <a:p>
             <a:pPr algn="ctr"/>
-            <a:endParaRPr/>
           </a:p>
         </p:txBody>
       </p:sp>
@@ -9697,7 +9603,6 @@
           <a:lstStyle/>
           <a:p>
             <a:pPr algn="ctr"/>
-            <a:endParaRPr/>
           </a:p>
         </p:txBody>
       </p:sp>
@@ -9874,7 +9779,6 @@
           <a:lstStyle/>
           <a:p>
             <a:pPr algn="ctr"/>
-            <a:endParaRPr/>
           </a:p>
         </p:txBody>
       </p:sp>
@@ -10051,7 +9955,6 @@
           <a:lstStyle/>
           <a:p>
             <a:pPr algn="ctr"/>
-            <a:endParaRPr/>
           </a:p>
         </p:txBody>
       </p:sp>
@@ -10279,7 +10182,7 @@
 </file>
 
 <file path=ppt/slides/slide3.xml><?xml version="1.0" encoding="utf-8"?>
-<p:sld xmlns:a="http://schemas.openxmlformats.org/drawingml/2006/main" xmlns:r="http://schemas.openxmlformats.org/officeDocument/2006/relationships" xmlns:p="http://schemas.openxmlformats.org/presentationml/2006/main">
+<p:sld xmlns:a="http://schemas.openxmlformats.org/drawingml/2006/main" xmlns:p="http://schemas.openxmlformats.org/presentationml/2006/main" xmlns:r="http://schemas.openxmlformats.org/officeDocument/2006/relationships">
   <p:cSld>
     <p:bg>
       <p:bgPr>
@@ -10295,14 +10198,7 @@
         <p:cNvGrpSpPr/>
         <p:nvPr/>
       </p:nvGrpSpPr>
-      <p:grpSpPr>
-        <a:xfrm>
-          <a:off x="0" y="0"/>
-          <a:ext cx="0" cy="0"/>
-          <a:chOff x="0" y="0"/>
-          <a:chExt cx="0" cy="0"/>
-        </a:xfrm>
-      </p:grpSpPr>
+      <p:grpSpPr/>
       <p:sp>
         <p:nvSpPr>
           <p:cNvPr id="2" name="Rectangle 1"/>
@@ -10343,7 +10239,6 @@
           <a:lstStyle/>
           <a:p>
             <a:pPr algn="ctr"/>
-            <a:endParaRPr/>
           </a:p>
         </p:txBody>
       </p:sp>
@@ -10520,7 +10415,6 @@
           <a:lstStyle/>
           <a:p>
             <a:pPr algn="ctr"/>
-            <a:endParaRPr/>
           </a:p>
         </p:txBody>
       </p:sp>
@@ -10689,7 +10583,6 @@
           <a:lstStyle/>
           <a:p>
             <a:pPr algn="ctr"/>
-            <a:endParaRPr/>
           </a:p>
         </p:txBody>
       </p:sp>
@@ -10854,7 +10747,6 @@
           <a:lstStyle/>
           <a:p>
             <a:pPr algn="ctr"/>
-            <a:endParaRPr/>
           </a:p>
         </p:txBody>
       </p:sp>
@@ -10965,7 +10857,7 @@
 </file>
 
 <file path=ppt/slides/slide4.xml><?xml version="1.0" encoding="utf-8"?>
-<p:sld xmlns:a="http://schemas.openxmlformats.org/drawingml/2006/main" xmlns:r="http://schemas.openxmlformats.org/officeDocument/2006/relationships" xmlns:p="http://schemas.openxmlformats.org/presentationml/2006/main">
+<p:sld xmlns:a="http://schemas.openxmlformats.org/drawingml/2006/main" xmlns:p="http://schemas.openxmlformats.org/presentationml/2006/main" xmlns:r="http://schemas.openxmlformats.org/officeDocument/2006/relationships">
   <p:cSld>
     <p:bg>
       <p:bgPr>
@@ -10981,14 +10873,7 @@
         <p:cNvGrpSpPr/>
         <p:nvPr/>
       </p:nvGrpSpPr>
-      <p:grpSpPr>
-        <a:xfrm>
-          <a:off x="0" y="0"/>
-          <a:ext cx="0" cy="0"/>
-          <a:chOff x="0" y="0"/>
-          <a:chExt cx="0" cy="0"/>
-        </a:xfrm>
-      </p:grpSpPr>
+      <p:grpSpPr/>
       <p:sp>
         <p:nvSpPr>
           <p:cNvPr id="2" name="Rectangle 1"/>
@@ -11029,7 +10914,6 @@
           <a:lstStyle/>
           <a:p>
             <a:pPr algn="ctr"/>
-            <a:endParaRPr/>
           </a:p>
         </p:txBody>
       </p:sp>
@@ -11206,7 +11090,6 @@
           <a:lstStyle/>
           <a:p>
             <a:pPr algn="ctr"/>
-            <a:endParaRPr/>
           </a:p>
         </p:txBody>
       </p:sp>
@@ -11561,7 +11444,7 @@
 </file>
 
 <file path=ppt/slides/slide5.xml><?xml version="1.0" encoding="utf-8"?>
-<p:sld xmlns:a="http://schemas.openxmlformats.org/drawingml/2006/main" xmlns:r="http://schemas.openxmlformats.org/officeDocument/2006/relationships" xmlns:p="http://schemas.openxmlformats.org/presentationml/2006/main">
+<p:sld xmlns:a="http://schemas.openxmlformats.org/drawingml/2006/main" xmlns:p="http://schemas.openxmlformats.org/presentationml/2006/main" xmlns:r="http://schemas.openxmlformats.org/officeDocument/2006/relationships">
   <p:cSld>
     <p:bg>
       <p:bgPr>
@@ -11577,14 +11460,7 @@
         <p:cNvGrpSpPr/>
         <p:nvPr/>
       </p:nvGrpSpPr>
-      <p:grpSpPr>
-        <a:xfrm>
-          <a:off x="0" y="0"/>
-          <a:ext cx="0" cy="0"/>
-          <a:chOff x="0" y="0"/>
-          <a:chExt cx="0" cy="0"/>
-        </a:xfrm>
-      </p:grpSpPr>
+      <p:grpSpPr/>
       <p:sp>
         <p:nvSpPr>
           <p:cNvPr id="2" name="Rectangle 1"/>
@@ -11625,7 +11501,6 @@
           <a:lstStyle/>
           <a:p>
             <a:pPr algn="ctr"/>
-            <a:endParaRPr/>
           </a:p>
         </p:txBody>
       </p:sp>
@@ -11802,7 +11677,6 @@
           <a:lstStyle/>
           <a:p>
             <a:pPr algn="ctr"/>
-            <a:endParaRPr/>
           </a:p>
         </p:txBody>
       </p:sp>
@@ -11952,7 +11826,6 @@
           <a:lstStyle/>
           <a:p>
             <a:pPr algn="ctr"/>
-            <a:endParaRPr/>
           </a:p>
         </p:txBody>
       </p:sp>
@@ -12075,7 +11948,6 @@
           <a:lstStyle/>
           <a:p>
             <a:pPr algn="ctr"/>
-            <a:endParaRPr/>
           </a:p>
         </p:txBody>
       </p:sp>
@@ -12259,7 +12131,6 @@
           <a:lstStyle/>
           <a:p>
             <a:pPr algn="ctr"/>
-            <a:endParaRPr/>
           </a:p>
         </p:txBody>
       </p:sp>
@@ -12343,7 +12214,7 @@
 </file>
 
 <file path=ppt/slides/slide6.xml><?xml version="1.0" encoding="utf-8"?>
-<p:sld xmlns:a="http://schemas.openxmlformats.org/drawingml/2006/main" xmlns:r="http://schemas.openxmlformats.org/officeDocument/2006/relationships" xmlns:p="http://schemas.openxmlformats.org/presentationml/2006/main">
+<p:sld xmlns:a="http://schemas.openxmlformats.org/drawingml/2006/main" xmlns:p="http://schemas.openxmlformats.org/presentationml/2006/main" xmlns:r="http://schemas.openxmlformats.org/officeDocument/2006/relationships">
   <p:cSld>
     <p:bg>
       <p:bgPr>
@@ -12359,14 +12230,7 @@
         <p:cNvGrpSpPr/>
         <p:nvPr/>
       </p:nvGrpSpPr>
-      <p:grpSpPr>
-        <a:xfrm>
-          <a:off x="0" y="0"/>
-          <a:ext cx="0" cy="0"/>
-          <a:chOff x="0" y="0"/>
-          <a:chExt cx="0" cy="0"/>
-        </a:xfrm>
-      </p:grpSpPr>
+      <p:grpSpPr/>
       <p:sp>
         <p:nvSpPr>
           <p:cNvPr id="2" name="Rectangle 1"/>
@@ -12407,7 +12271,6 @@
           <a:lstStyle/>
           <a:p>
             <a:pPr algn="ctr"/>
-            <a:endParaRPr/>
           </a:p>
         </p:txBody>
       </p:sp>
@@ -12584,7 +12447,6 @@
           <a:lstStyle/>
           <a:p>
             <a:pPr algn="ctr"/>
-            <a:endParaRPr/>
           </a:p>
         </p:txBody>
       </p:sp>
@@ -12628,7 +12490,6 @@
           <a:lstStyle/>
           <a:p>
             <a:pPr algn="ctr"/>
-            <a:endParaRPr/>
           </a:p>
         </p:txBody>
       </p:sp>
@@ -12787,8 +12648,8 @@
         </p:nvSpPr>
         <p:spPr>
           <a:xfrm>
-            <a:off x="6583680" y="4754880"/>
-            <a:ext cx="5029200" cy="1554480"/>
+            <a:off x="6583680" y="5120640"/>
+            <a:ext cx="5029200" cy="1188720"/>
           </a:xfrm>
           <a:prstGeom prst="rect">
             <a:avLst/>
@@ -12814,16 +12675,7 @@
               </a:defRPr>
             </a:pPr>
             <a:r>
-              <a:rPr dirty="0"/>
-              <a:t>💡 </a:t>
-            </a:r>
-            <a:r>
-              <a:rPr dirty="0" err="1"/>
-              <a:t>问题分析</a:t>
-            </a:r>
-            <a:r>
-              <a:rPr dirty="0"/>
-              <a:t>：</a:t>
+              <a:t>💡 问题分析：</a:t>
             </a:r>
           </a:p>
           <a:p>
@@ -12841,7 +12693,6 @@
                 <a:latin typeface="Microsoft YaHei"/>
               </a:defRPr>
             </a:pPr>
-            <a:endParaRPr dirty="0"/>
           </a:p>
           <a:p>
             <a:pPr algn="l">
@@ -12859,16 +12710,7 @@
               </a:defRPr>
             </a:pPr>
             <a:r>
-              <a:rPr dirty="0"/>
-              <a:t>   Claude </a:t>
-            </a:r>
-            <a:r>
-              <a:rPr dirty="0" err="1"/>
-              <a:t>是国外大模型，需要</a:t>
-            </a:r>
-            <a:r>
-              <a:rPr dirty="0"/>
-              <a:t>：</a:t>
+              <a:t>   Claude 是国外大模型，需要：</a:t>
             </a:r>
           </a:p>
           <a:p>
@@ -12887,14 +12729,8 @@
               </a:defRPr>
             </a:pPr>
             <a:r>
-              <a:rPr dirty="0"/>
-              <a:t>   · </a:t>
-            </a:r>
-            <a:r>
-              <a:rPr dirty="0" err="1"/>
-              <a:t>科学上网才能访问</a:t>
-            </a:r>
-            <a:endParaRPr dirty="0"/>
+              <a:t>   · 科学上网才能访问</a:t>
+            </a:r>
           </a:p>
           <a:p>
             <a:pPr algn="l">
@@ -12912,24 +12748,7 @@
               </a:defRPr>
             </a:pPr>
             <a:r>
-              <a:rPr dirty="0"/>
-              <a:t>   · </a:t>
-            </a:r>
-            <a:r>
-              <a:rPr dirty="0" err="1"/>
-              <a:t>付费购买</a:t>
-            </a:r>
-            <a:r>
-              <a:rPr dirty="0"/>
-              <a:t> </a:t>
-            </a:r>
-            <a:r>
-              <a:rPr dirty="0" err="1"/>
-              <a:t>token（价格昂贵</a:t>
-            </a:r>
-            <a:r>
-              <a:rPr dirty="0"/>
-              <a:t>）</a:t>
+              <a:t>   · 付费购买 token（价格昂贵）</a:t>
             </a:r>
           </a:p>
           <a:p>
@@ -12948,14 +12767,8 @@
               </a:defRPr>
             </a:pPr>
             <a:r>
-              <a:rPr dirty="0"/>
-              <a:t>   · </a:t>
-            </a:r>
-            <a:r>
-              <a:rPr dirty="0" err="1"/>
-              <a:t>账号经常被封</a:t>
-            </a:r>
-            <a:endParaRPr dirty="0"/>
+              <a:t>   · 账号经常被封</a:t>
+            </a:r>
           </a:p>
           <a:p>
             <a:pPr algn="l">
@@ -12972,7 +12785,6 @@
                 <a:latin typeface="Microsoft YaHei"/>
               </a:defRPr>
             </a:pPr>
-            <a:endParaRPr dirty="0"/>
           </a:p>
           <a:p>
             <a:pPr algn="l">
@@ -12990,24 +12802,7 @@
               </a:defRPr>
             </a:pPr>
             <a:r>
-              <a:rPr dirty="0"/>
-              <a:t>   👉 </a:t>
-            </a:r>
-            <a:r>
-              <a:rPr dirty="0" err="1"/>
-              <a:t>解决方案：接入国产</a:t>
-            </a:r>
-            <a:r>
-              <a:rPr dirty="0"/>
-              <a:t> </a:t>
-            </a:r>
-            <a:r>
-              <a:rPr dirty="0" err="1"/>
-              <a:t>DeepSeek</a:t>
-            </a:r>
-            <a:r>
-              <a:rPr dirty="0"/>
-              <a:t>！</a:t>
+              <a:t>   👉 解决方案：接入国产 DeepSeek！</a:t>
             </a:r>
           </a:p>
         </p:txBody>
@@ -13021,7 +12816,7 @@
 </file>
 
 <file path=ppt/slides/slide7.xml><?xml version="1.0" encoding="utf-8"?>
-<p:sld xmlns:a="http://schemas.openxmlformats.org/drawingml/2006/main" xmlns:r="http://schemas.openxmlformats.org/officeDocument/2006/relationships" xmlns:p="http://schemas.openxmlformats.org/presentationml/2006/main">
+<p:sld xmlns:a="http://schemas.openxmlformats.org/drawingml/2006/main" xmlns:p="http://schemas.openxmlformats.org/presentationml/2006/main" xmlns:r="http://schemas.openxmlformats.org/officeDocument/2006/relationships">
   <p:cSld>
     <p:bg>
       <p:bgPr>
@@ -13037,14 +12832,7 @@
         <p:cNvGrpSpPr/>
         <p:nvPr/>
       </p:nvGrpSpPr>
-      <p:grpSpPr>
-        <a:xfrm>
-          <a:off x="0" y="0"/>
-          <a:ext cx="0" cy="0"/>
-          <a:chOff x="0" y="0"/>
-          <a:chExt cx="0" cy="0"/>
-        </a:xfrm>
-      </p:grpSpPr>
+      <p:grpSpPr/>
       <p:sp>
         <p:nvSpPr>
           <p:cNvPr id="2" name="Rectangle 1"/>
@@ -13085,7 +12873,6 @@
           <a:lstStyle/>
           <a:p>
             <a:pPr algn="ctr"/>
-            <a:endParaRPr/>
           </a:p>
         </p:txBody>
       </p:sp>
@@ -13262,7 +13049,6 @@
           <a:lstStyle/>
           <a:p>
             <a:pPr algn="ctr"/>
-            <a:endParaRPr/>
           </a:p>
         </p:txBody>
       </p:sp>
@@ -13306,7 +13092,6 @@
           <a:lstStyle/>
           <a:p>
             <a:pPr algn="ctr"/>
-            <a:endParaRPr/>
           </a:p>
         </p:txBody>
       </p:sp>
@@ -13506,7 +13291,7 @@
 </file>
 
 <file path=ppt/slides/slide8.xml><?xml version="1.0" encoding="utf-8"?>
-<p:sld xmlns:a="http://schemas.openxmlformats.org/drawingml/2006/main" xmlns:r="http://schemas.openxmlformats.org/officeDocument/2006/relationships" xmlns:p="http://schemas.openxmlformats.org/presentationml/2006/main">
+<p:sld xmlns:a="http://schemas.openxmlformats.org/drawingml/2006/main" xmlns:p="http://schemas.openxmlformats.org/presentationml/2006/main" xmlns:r="http://schemas.openxmlformats.org/officeDocument/2006/relationships">
   <p:cSld>
     <p:bg>
       <p:bgPr>
@@ -13522,14 +13307,7 @@
         <p:cNvGrpSpPr/>
         <p:nvPr/>
       </p:nvGrpSpPr>
-      <p:grpSpPr>
-        <a:xfrm>
-          <a:off x="0" y="0"/>
-          <a:ext cx="0" cy="0"/>
-          <a:chOff x="0" y="0"/>
-          <a:chExt cx="0" cy="0"/>
-        </a:xfrm>
-      </p:grpSpPr>
+      <p:grpSpPr/>
       <p:sp>
         <p:nvSpPr>
           <p:cNvPr id="2" name="Rectangle 1"/>
@@ -13570,7 +13348,6 @@
           <a:lstStyle/>
           <a:p>
             <a:pPr algn="ctr"/>
-            <a:endParaRPr/>
           </a:p>
         </p:txBody>
       </p:sp>
@@ -13747,7 +13524,6 @@
           <a:lstStyle/>
           <a:p>
             <a:pPr algn="ctr"/>
-            <a:endParaRPr/>
           </a:p>
         </p:txBody>
       </p:sp>
@@ -13791,7 +13567,6 @@
           <a:lstStyle/>
           <a:p>
             <a:pPr algn="ctr"/>
-            <a:endParaRPr/>
           </a:p>
         </p:txBody>
       </p:sp>
@@ -14022,7 +13797,6 @@
           <a:lstStyle/>
           <a:p>
             <a:pPr algn="ctr"/>
-            <a:endParaRPr/>
           </a:p>
         </p:txBody>
       </p:sp>
@@ -14079,7 +13853,6 @@
                 <a:latin typeface="Microsoft YaHei"/>
               </a:defRPr>
             </a:pPr>
-            <a:endParaRPr/>
           </a:p>
           <a:p>
             <a:pPr algn="l">
@@ -14168,7 +13941,7 @@
 </file>
 
 <file path=ppt/slides/slide9.xml><?xml version="1.0" encoding="utf-8"?>
-<p:sld xmlns:a="http://schemas.openxmlformats.org/drawingml/2006/main" xmlns:r="http://schemas.openxmlformats.org/officeDocument/2006/relationships" xmlns:p="http://schemas.openxmlformats.org/presentationml/2006/main">
+<p:sld xmlns:a="http://schemas.openxmlformats.org/drawingml/2006/main" xmlns:p="http://schemas.openxmlformats.org/presentationml/2006/main" xmlns:r="http://schemas.openxmlformats.org/officeDocument/2006/relationships">
   <p:cSld>
     <p:bg>
       <p:bgPr>
@@ -14184,14 +13957,7 @@
         <p:cNvGrpSpPr/>
         <p:nvPr/>
       </p:nvGrpSpPr>
-      <p:grpSpPr>
-        <a:xfrm>
-          <a:off x="0" y="0"/>
-          <a:ext cx="0" cy="0"/>
-          <a:chOff x="0" y="0"/>
-          <a:chExt cx="0" cy="0"/>
-        </a:xfrm>
-      </p:grpSpPr>
+      <p:grpSpPr/>
       <p:sp>
         <p:nvSpPr>
           <p:cNvPr id="2" name="Rectangle 1"/>
@@ -14232,7 +13998,6 @@
           <a:lstStyle/>
           <a:p>
             <a:pPr algn="ctr"/>
-            <a:endParaRPr/>
           </a:p>
         </p:txBody>
       </p:sp>
@@ -14356,7 +14121,6 @@
           <a:lstStyle/>
           <a:p>
             <a:pPr algn="ctr"/>
-            <a:endParaRPr/>
           </a:p>
         </p:txBody>
       </p:sp>
@@ -14400,7 +14164,6 @@
           <a:lstStyle/>
           <a:p>
             <a:pPr algn="ctr"/>
-            <a:endParaRPr/>
           </a:p>
         </p:txBody>
       </p:sp>

</xml_diff>